<commit_message>
Presentation: use the thesis title on the title slide
</commit_message>
<xml_diff>
--- a/60_Final_Presentation/colloquium_slides.pptx
+++ b/60_Final_Presentation/colloquium_slides.pptx
@@ -4842,7 +4842,7 @@
         <p:spPr>
           <a:xfrm>
             <a:off x="640080" y="1280160"/>
-            <a:ext cx="5074920" cy="2377440"/>
+            <a:ext cx="5120640" cy="3108960"/>
           </a:xfrm>
           <a:prstGeom prst="rect">
             <a:avLst/>
@@ -4864,13 +4864,13 @@
               </a:spcAft>
             </a:pPr>
             <a:r>
-              <a:rPr sz="3800" b="0" i="0">
+              <a:rPr sz="3200" b="0" i="0">
                 <a:solidFill>
                   <a:srgbClr val="FFFFFF"/>
                 </a:solidFill>
                 <a:latin typeface="Bahnschrift SemiBold"/>
               </a:rPr>
-              <a:t>Reading the battery of a VW ID. Buzz through the OBD-II port</a:t>
+              <a:t>Identification and Interpretation of BMS Signals Through CAN Bus Reverse Engineering on the Volkswagen ID. Buzz</a:t>
             </a:r>
           </a:p>
         </p:txBody>
@@ -4878,48 +4878,6 @@
       <p:sp>
         <p:nvSpPr>
           <p:cNvPr id="7" name="TextBox 6"/>
-          <p:cNvSpPr txBox="1"/>
-          <p:nvPr/>
-        </p:nvSpPr>
-        <p:spPr>
-          <a:xfrm>
-            <a:off x="640080" y="3611880"/>
-            <a:ext cx="4937760" cy="914400"/>
-          </a:xfrm>
-          <a:prstGeom prst="rect">
-            <a:avLst/>
-          </a:prstGeom>
-          <a:noFill/>
-        </p:spPr>
-        <p:txBody>
-          <a:bodyPr wrap="square" lIns="0" rIns="0" tIns="0" bIns="0" anchor="t">
-            <a:spAutoFit/>
-          </a:bodyPr>
-          <a:lstStyle/>
-          <a:p>
-            <a:pPr algn="l">
-              <a:lnSpc>
-                <a:spcPct val="100000"/>
-              </a:lnSpc>
-              <a:spcAft>
-                <a:spcPts val="0"/>
-              </a:spcAft>
-            </a:pPr>
-            <a:r>
-              <a:rPr sz="1400" b="0" i="0">
-                <a:solidFill>
-                  <a:srgbClr val="B8C2CC"/>
-                </a:solidFill>
-                <a:latin typeface="Calibri"/>
-              </a:rPr>
-              <a:t>Identification and Interpretation of BMS Signals Through CAN Bus Reverse Engineering on the Volkswagen ID. Buzz</a:t>
-            </a:r>
-          </a:p>
-        </p:txBody>
-      </p:sp>
-      <p:sp>
-        <p:nvSpPr>
-          <p:cNvPr id="8" name="TextBox 7"/>
           <p:cNvSpPr txBox="1"/>
           <p:nvPr/>
         </p:nvSpPr>

</xml_diff>